<commit_message>
docs: add before/after thumbnails and use @/{} placeholders in vignette
- Update example pptx to include both slides (slide 1: {1}/@, slide 2: [2]/[])
- Add before/after PNG thumbnails showing format preservation
- Use standard @/{} placeholders in vignette examples
- Add multi-slide tests covering both slides
- Update example script to match
</commit_message>
<xml_diff>
--- a/inst/ext/pptx/text_replace.pptx
+++ b/inst/ext/pptx/text_replace.pptx
@@ -6,11 +6,12 @@
   </p:sldMasterIdLst>
   <p:sldIdLst>
     <p:sldId id="256" r:id="rId2"/>
+    <p:sldId id="257" r:id="rId3"/>
   </p:sldIdLst>
   <p:sldSz cx="9144000" cy="6858000" type="screen4x3"/>
   <p:notesSz cx="6858000" cy="9144000"/>
   <p:custDataLst>
-    <p:tags r:id="rId3"/>
+    <p:tags r:id="rId4"/>
   </p:custDataLst>
   <p:defaultTextStyle>
     <a:defPPr>
@@ -307,7 +308,7 @@
           <a:p>
             <a:fld id="{E6744CE3-0875-4B69-89C0-6F72D8139561}" type="datetimeFigureOut">
               <a:rPr lang="en-GB" smtClean="0"/>
-              <a:t>24/05/2024</a:t>
+              <a:t>15/08/2026</a:t>
             </a:fld>
             <a:endParaRPr lang="en-GB"/>
           </a:p>
@@ -477,7 +478,7 @@
           <a:p>
             <a:fld id="{E6744CE3-0875-4B69-89C0-6F72D8139561}" type="datetimeFigureOut">
               <a:rPr lang="en-GB" smtClean="0"/>
-              <a:t>24/05/2024</a:t>
+              <a:t>15/08/2026</a:t>
             </a:fld>
             <a:endParaRPr lang="en-GB"/>
           </a:p>
@@ -723,7 +724,7 @@
           <a:p>
             <a:fld id="{E6744CE3-0875-4B69-89C0-6F72D8139561}" type="datetimeFigureOut">
               <a:rPr lang="en-GB" smtClean="0"/>
-              <a:t>24/05/2024</a:t>
+              <a:t>15/08/2026</a:t>
             </a:fld>
             <a:endParaRPr lang="en-GB"/>
           </a:p>
@@ -1011,7 +1012,7 @@
           <a:p>
             <a:fld id="{E6744CE3-0875-4B69-89C0-6F72D8139561}" type="datetimeFigureOut">
               <a:rPr lang="en-GB" smtClean="0"/>
-              <a:t>24/05/2024</a:t>
+              <a:t>15/08/2026</a:t>
             </a:fld>
             <a:endParaRPr lang="en-GB"/>
           </a:p>
@@ -1433,7 +1434,7 @@
           <a:p>
             <a:fld id="{E6744CE3-0875-4B69-89C0-6F72D8139561}" type="datetimeFigureOut">
               <a:rPr lang="en-GB" smtClean="0"/>
-              <a:t>24/05/2024</a:t>
+              <a:t>15/08/2026</a:t>
             </a:fld>
             <a:endParaRPr lang="en-GB"/>
           </a:p>
@@ -1551,7 +1552,7 @@
           <a:p>
             <a:fld id="{E6744CE3-0875-4B69-89C0-6F72D8139561}" type="datetimeFigureOut">
               <a:rPr lang="en-GB" smtClean="0"/>
-              <a:t>24/05/2024</a:t>
+              <a:t>15/08/2026</a:t>
             </a:fld>
             <a:endParaRPr lang="en-GB"/>
           </a:p>
@@ -1646,7 +1647,7 @@
           <a:p>
             <a:fld id="{E6744CE3-0875-4B69-89C0-6F72D8139561}" type="datetimeFigureOut">
               <a:rPr lang="en-GB" smtClean="0"/>
-              <a:t>24/05/2024</a:t>
+              <a:t>15/08/2026</a:t>
             </a:fld>
             <a:endParaRPr lang="en-GB"/>
           </a:p>
@@ -1859,7 +1860,7 @@
           <a:p>
             <a:fld id="{E6744CE3-0875-4B69-89C0-6F72D8139561}" type="datetimeFigureOut">
               <a:rPr lang="en-GB" smtClean="0"/>
-              <a:t>24/05/2024</a:t>
+              <a:t>15/08/2026</a:t>
             </a:fld>
             <a:endParaRPr lang="en-GB"/>
           </a:p>
@@ -2960,6 +2961,760 @@
     <p:extLst>
       <p:ext uri="{BB962C8B-B14F-4D97-AF65-F5344CB8AC3E}">
         <p14:creationId xmlns:p14="http://schemas.microsoft.com/office/powerpoint/2010/main" val="3228154931"/>
+      </p:ext>
+    </p:extLst>
+  </p:cSld>
+  <p:clrMapOvr>
+    <a:masterClrMapping/>
+  </p:clrMapOvr>
+</p:sld>
+</file>
+
+<file path=ppt/slides/slide2.xml><?xml version="1.0" encoding="utf-8"?>
+<p:sld xmlns:a="http://schemas.openxmlformats.org/drawingml/2006/main" xmlns:r="http://schemas.openxmlformats.org/officeDocument/2006/relationships" xmlns:p="http://schemas.openxmlformats.org/presentationml/2006/main">
+  <p:cSld>
+    <p:spTree>
+      <p:nvGrpSpPr>
+        <p:cNvPr id="1" name="">
+          <a:extLst>
+            <a:ext uri="{FF2B5EF4-FFF2-40B4-BE49-F238E27FC236}">
+              <a16:creationId xmlns:a16="http://schemas.microsoft.com/office/drawing/2014/main" id="{DF58DA9C-D112-D052-4BFA-B1C4368B40C6}"/>
+            </a:ext>
+          </a:extLst>
+        </p:cNvPr>
+        <p:cNvGrpSpPr/>
+        <p:nvPr/>
+      </p:nvGrpSpPr>
+      <p:grpSpPr>
+        <a:xfrm>
+          <a:off x="0" y="0"/>
+          <a:ext cx="0" cy="0"/>
+          <a:chOff x="0" y="0"/>
+          <a:chExt cx="0" cy="0"/>
+        </a:xfrm>
+      </p:grpSpPr>
+      <p:sp>
+        <p:nvSpPr>
+          <p:cNvPr id="4" name="Titel 3">
+            <a:extLst>
+              <a:ext uri="{FF2B5EF4-FFF2-40B4-BE49-F238E27FC236}">
+                <a16:creationId xmlns:a16="http://schemas.microsoft.com/office/drawing/2014/main" id="{677C6AD5-3AA7-5663-D116-682D1B871C19}"/>
+              </a:ext>
+            </a:extLst>
+          </p:cNvPr>
+          <p:cNvSpPr>
+            <a:spLocks noGrp="1"/>
+          </p:cNvSpPr>
+          <p:nvPr>
+            <p:ph type="title"/>
+          </p:nvPr>
+        </p:nvSpPr>
+        <p:spPr/>
+        <p:txBody>
+          <a:bodyPr/>
+          <a:lstStyle/>
+          <a:p>
+            <a:r>
+              <a:rPr lang="de-DE" dirty="0"/>
+              <a:t>Header to </a:t>
+            </a:r>
+            <a:r>
+              <a:rPr lang="de-DE" dirty="0" err="1"/>
+              <a:t>replace</a:t>
+            </a:r>
+            <a:r>
+              <a:rPr lang="de-DE" dirty="0"/>
+              <a:t> </a:t>
+            </a:r>
+            <a:r>
+              <a:rPr lang="de-DE" b="1" dirty="0">
+                <a:highlight>
+                  <a:srgbClr val="FFFF00"/>
+                </a:highlight>
+              </a:rPr>
+              <a:t>[2]</a:t>
+            </a:r>
+            <a:r>
+              <a:rPr lang="de-DE" b="1" dirty="0"/>
+              <a:t> </a:t>
+            </a:r>
+            <a:r>
+              <a:rPr lang="de-DE" b="1" u="sng" dirty="0">
+                <a:solidFill>
+                  <a:srgbClr val="0070C0"/>
+                </a:solidFill>
+                <a:highlight>
+                  <a:srgbClr val="C0C0C0"/>
+                </a:highlight>
+              </a:rPr>
+              <a:t>[[2]]</a:t>
+            </a:r>
+          </a:p>
+        </p:txBody>
+      </p:sp>
+      <p:sp>
+        <p:nvSpPr>
+          <p:cNvPr id="5" name="Textplatzhalter 3">
+            <a:extLst>
+              <a:ext uri="{FF2B5EF4-FFF2-40B4-BE49-F238E27FC236}">
+                <a16:creationId xmlns:a16="http://schemas.microsoft.com/office/drawing/2014/main" id="{AB3E2EB2-FA1E-F69E-5E2E-562E1EC10F24}"/>
+              </a:ext>
+            </a:extLst>
+          </p:cNvPr>
+          <p:cNvSpPr txBox="1">
+            <a:spLocks/>
+          </p:cNvSpPr>
+          <p:nvPr/>
+        </p:nvSpPr>
+        <p:spPr>
+          <a:xfrm>
+            <a:off x="371474" y="1436925"/>
+            <a:ext cx="8315325" cy="4212507"/>
+          </a:xfrm>
+          <a:prstGeom prst="rect">
+            <a:avLst/>
+          </a:prstGeom>
+        </p:spPr>
+        <p:txBody>
+          <a:bodyPr/>
+          <a:lstStyle>
+            <a:lvl1pPr marL="342900" indent="-342900" algn="l" defTabSz="914400" rtl="0" eaLnBrk="1" latinLnBrk="0" hangingPunct="1">
+              <a:spcBef>
+                <a:spcPct val="20000"/>
+              </a:spcBef>
+              <a:buFont typeface="Arial" panose="020B0604020202020204" pitchFamily="34" charset="0"/>
+              <a:buChar char="•"/>
+              <a:defRPr sz="3200" kern="1200">
+                <a:solidFill>
+                  <a:schemeClr val="tx1"/>
+                </a:solidFill>
+                <a:latin typeface="+mn-lt"/>
+                <a:ea typeface="+mn-ea"/>
+                <a:cs typeface="+mn-cs"/>
+              </a:defRPr>
+            </a:lvl1pPr>
+            <a:lvl2pPr marL="742950" indent="-285750" algn="l" defTabSz="914400" rtl="0" eaLnBrk="1" latinLnBrk="0" hangingPunct="1">
+              <a:spcBef>
+                <a:spcPct val="20000"/>
+              </a:spcBef>
+              <a:buFont typeface="Arial" panose="020B0604020202020204" pitchFamily="34" charset="0"/>
+              <a:buChar char="–"/>
+              <a:defRPr sz="2800" kern="1200">
+                <a:solidFill>
+                  <a:schemeClr val="tx1"/>
+                </a:solidFill>
+                <a:latin typeface="+mn-lt"/>
+                <a:ea typeface="+mn-ea"/>
+                <a:cs typeface="+mn-cs"/>
+              </a:defRPr>
+            </a:lvl2pPr>
+            <a:lvl3pPr marL="1143000" indent="-228600" algn="l" defTabSz="914400" rtl="0" eaLnBrk="1" latinLnBrk="0" hangingPunct="1">
+              <a:spcBef>
+                <a:spcPct val="20000"/>
+              </a:spcBef>
+              <a:buFont typeface="Arial" panose="020B0604020202020204" pitchFamily="34" charset="0"/>
+              <a:buChar char="•"/>
+              <a:defRPr sz="2400" kern="1200">
+                <a:solidFill>
+                  <a:schemeClr val="tx1"/>
+                </a:solidFill>
+                <a:latin typeface="+mn-lt"/>
+                <a:ea typeface="+mn-ea"/>
+                <a:cs typeface="+mn-cs"/>
+              </a:defRPr>
+            </a:lvl3pPr>
+            <a:lvl4pPr marL="1600200" indent="-228600" algn="l" defTabSz="914400" rtl="0" eaLnBrk="1" latinLnBrk="0" hangingPunct="1">
+              <a:spcBef>
+                <a:spcPct val="20000"/>
+              </a:spcBef>
+              <a:buFont typeface="Arial" panose="020B0604020202020204" pitchFamily="34" charset="0"/>
+              <a:buChar char="–"/>
+              <a:defRPr sz="2000" kern="1200">
+                <a:solidFill>
+                  <a:schemeClr val="tx1"/>
+                </a:solidFill>
+                <a:latin typeface="+mn-lt"/>
+                <a:ea typeface="+mn-ea"/>
+                <a:cs typeface="+mn-cs"/>
+              </a:defRPr>
+            </a:lvl4pPr>
+            <a:lvl5pPr marL="2057400" indent="-228600" algn="l" defTabSz="914400" rtl="0" eaLnBrk="1" latinLnBrk="0" hangingPunct="1">
+              <a:spcBef>
+                <a:spcPct val="20000"/>
+              </a:spcBef>
+              <a:buFont typeface="Arial" panose="020B0604020202020204" pitchFamily="34" charset="0"/>
+              <a:buChar char="»"/>
+              <a:defRPr sz="2000" kern="1200">
+                <a:solidFill>
+                  <a:schemeClr val="tx1"/>
+                </a:solidFill>
+                <a:latin typeface="+mn-lt"/>
+                <a:ea typeface="+mn-ea"/>
+                <a:cs typeface="+mn-cs"/>
+              </a:defRPr>
+            </a:lvl5pPr>
+            <a:lvl6pPr marL="2514600" indent="-228600" algn="l" defTabSz="914400" rtl="0" eaLnBrk="1" latinLnBrk="0" hangingPunct="1">
+              <a:spcBef>
+                <a:spcPct val="20000"/>
+              </a:spcBef>
+              <a:buFont typeface="Arial" panose="020B0604020202020204" pitchFamily="34" charset="0"/>
+              <a:buChar char="•"/>
+              <a:defRPr sz="2000" kern="1200">
+                <a:solidFill>
+                  <a:schemeClr val="tx1"/>
+                </a:solidFill>
+                <a:latin typeface="+mn-lt"/>
+                <a:ea typeface="+mn-ea"/>
+                <a:cs typeface="+mn-cs"/>
+              </a:defRPr>
+            </a:lvl6pPr>
+            <a:lvl7pPr marL="2971800" indent="-228600" algn="l" defTabSz="914400" rtl="0" eaLnBrk="1" latinLnBrk="0" hangingPunct="1">
+              <a:spcBef>
+                <a:spcPct val="20000"/>
+              </a:spcBef>
+              <a:buFont typeface="Arial" panose="020B0604020202020204" pitchFamily="34" charset="0"/>
+              <a:buChar char="•"/>
+              <a:defRPr sz="2000" kern="1200">
+                <a:solidFill>
+                  <a:schemeClr val="tx1"/>
+                </a:solidFill>
+                <a:latin typeface="+mn-lt"/>
+                <a:ea typeface="+mn-ea"/>
+                <a:cs typeface="+mn-cs"/>
+              </a:defRPr>
+            </a:lvl7pPr>
+            <a:lvl8pPr marL="3429000" indent="-228600" algn="l" defTabSz="914400" rtl="0" eaLnBrk="1" latinLnBrk="0" hangingPunct="1">
+              <a:spcBef>
+                <a:spcPct val="20000"/>
+              </a:spcBef>
+              <a:buFont typeface="Arial" panose="020B0604020202020204" pitchFamily="34" charset="0"/>
+              <a:buChar char="•"/>
+              <a:defRPr sz="2000" kern="1200">
+                <a:solidFill>
+                  <a:schemeClr val="tx1"/>
+                </a:solidFill>
+                <a:latin typeface="+mn-lt"/>
+                <a:ea typeface="+mn-ea"/>
+                <a:cs typeface="+mn-cs"/>
+              </a:defRPr>
+            </a:lvl8pPr>
+            <a:lvl9pPr marL="3886200" indent="-228600" algn="l" defTabSz="914400" rtl="0" eaLnBrk="1" latinLnBrk="0" hangingPunct="1">
+              <a:spcBef>
+                <a:spcPct val="20000"/>
+              </a:spcBef>
+              <a:buFont typeface="Arial" panose="020B0604020202020204" pitchFamily="34" charset="0"/>
+              <a:buChar char="•"/>
+              <a:defRPr sz="2000" kern="1200">
+                <a:solidFill>
+                  <a:schemeClr val="tx1"/>
+                </a:solidFill>
+                <a:latin typeface="+mn-lt"/>
+                <a:ea typeface="+mn-ea"/>
+                <a:cs typeface="+mn-cs"/>
+              </a:defRPr>
+            </a:lvl9pPr>
+          </a:lstStyle>
+          <a:p>
+            <a:pPr marL="0" indent="0">
+              <a:spcBef>
+                <a:spcPts val="0"/>
+              </a:spcBef>
+              <a:buFont typeface="Arial" panose="020B0604020202020204" pitchFamily="34" charset="0"/>
+              <a:buNone/>
+            </a:pPr>
+            <a:r>
+              <a:rPr lang="de-DE" dirty="0">
+                <a:solidFill>
+                  <a:srgbClr val="00B0F0"/>
+                </a:solidFill>
+              </a:rPr>
+              <a:t>[</a:t>
+            </a:r>
+            <a:r>
+              <a:rPr lang="de-DE" dirty="0">
+                <a:solidFill>
+                  <a:srgbClr val="FF0000"/>
+                </a:solidFill>
+              </a:rPr>
+              <a:t>2] </a:t>
+            </a:r>
+            <a:r>
+              <a:rPr lang="de-DE" dirty="0"/>
+              <a:t>and </a:t>
+            </a:r>
+            <a:r>
+              <a:rPr lang="de-DE" dirty="0">
+                <a:solidFill>
+                  <a:srgbClr val="FF0000"/>
+                </a:solidFill>
+                <a:highlight>
+                  <a:srgbClr val="84CFEF"/>
+                </a:highlight>
+              </a:rPr>
+              <a:t>[2</a:t>
+            </a:r>
+            <a:r>
+              <a:rPr lang="de-DE" dirty="0">
+                <a:solidFill>
+                  <a:srgbClr val="FF0000"/>
+                </a:solidFill>
+              </a:rPr>
+              <a:t>] </a:t>
+            </a:r>
+            <a:r>
+              <a:rPr lang="de-DE" dirty="0"/>
+              <a:t>and </a:t>
+            </a:r>
+            <a:r>
+              <a:rPr lang="de-DE" sz="2000" dirty="0"/>
+              <a:t>[2</a:t>
+            </a:r>
+            <a:r>
+              <a:rPr lang="de-DE" dirty="0"/>
+              <a:t>]</a:t>
+            </a:r>
+          </a:p>
+          <a:p>
+            <a:pPr marL="0" indent="0">
+              <a:spcBef>
+                <a:spcPts val="0"/>
+              </a:spcBef>
+              <a:buFont typeface="Arial" panose="020B0604020202020204" pitchFamily="34" charset="0"/>
+              <a:buNone/>
+            </a:pPr>
+            <a:r>
+              <a:rPr lang="de-DE" dirty="0"/>
+              <a:t>xxx [2] xxx</a:t>
+            </a:r>
+          </a:p>
+          <a:p>
+            <a:pPr marL="0" indent="0">
+              <a:spcBef>
+                <a:spcPts val="0"/>
+              </a:spcBef>
+              <a:buFont typeface="Arial" panose="020B0604020202020204" pitchFamily="34" charset="0"/>
+              <a:buNone/>
+            </a:pPr>
+            <a:r>
+              <a:rPr lang="de-DE" dirty="0"/>
+              <a:t>xxx </a:t>
+            </a:r>
+            <a:r>
+              <a:rPr lang="de-DE" dirty="0">
+                <a:solidFill>
+                  <a:srgbClr val="00B0F0"/>
+                </a:solidFill>
+                <a:highlight>
+                  <a:srgbClr val="00FFFF"/>
+                </a:highlight>
+              </a:rPr>
+              <a:t>[</a:t>
+            </a:r>
+            <a:r>
+              <a:rPr lang="de-DE" dirty="0"/>
+              <a:t>2] xxx</a:t>
+            </a:r>
+            <a:endParaRPr lang="de-DE" dirty="0">
+              <a:solidFill>
+                <a:srgbClr val="00B0F0"/>
+              </a:solidFill>
+            </a:endParaRPr>
+          </a:p>
+          <a:p>
+            <a:pPr marL="0" indent="0">
+              <a:spcBef>
+                <a:spcPts val="0"/>
+              </a:spcBef>
+              <a:buFont typeface="Arial" panose="020B0604020202020204" pitchFamily="34" charset="0"/>
+              <a:buNone/>
+            </a:pPr>
+            <a:r>
+              <a:rPr lang="de-DE" dirty="0">
+                <a:solidFill>
+                  <a:srgbClr val="00B050"/>
+                </a:solidFill>
+              </a:rPr>
+              <a:t>xxx </a:t>
+            </a:r>
+            <a:r>
+              <a:rPr lang="de-DE" sz="1000" dirty="0">
+                <a:solidFill>
+                  <a:srgbClr val="00B050"/>
+                </a:solidFill>
+              </a:rPr>
+              <a:t>[</a:t>
+            </a:r>
+            <a:r>
+              <a:rPr lang="de-DE" dirty="0">
+                <a:solidFill>
+                  <a:srgbClr val="00B050"/>
+                </a:solidFill>
+              </a:rPr>
+              <a:t>2] xxx</a:t>
+            </a:r>
+          </a:p>
+          <a:p>
+            <a:pPr marL="0" indent="0">
+              <a:buFont typeface="Arial" panose="020B0604020202020204" pitchFamily="34" charset="0"/>
+              <a:buNone/>
+            </a:pPr>
+            <a:endParaRPr lang="de-DE" dirty="0">
+              <a:solidFill>
+                <a:srgbClr val="00B050"/>
+              </a:solidFill>
+            </a:endParaRPr>
+          </a:p>
+          <a:p>
+            <a:pPr marL="0" indent="0">
+              <a:spcBef>
+                <a:spcPts val="0"/>
+              </a:spcBef>
+              <a:buFont typeface="Arial" panose="020B0604020202020204" pitchFamily="34" charset="0"/>
+              <a:buNone/>
+            </a:pPr>
+            <a:r>
+              <a:rPr lang="de-DE" dirty="0">
+                <a:solidFill>
+                  <a:srgbClr val="00B0F0"/>
+                </a:solidFill>
+              </a:rPr>
+              <a:t>[]</a:t>
+            </a:r>
+            <a:r>
+              <a:rPr lang="de-DE" dirty="0">
+                <a:solidFill>
+                  <a:srgbClr val="FF0000"/>
+                </a:solidFill>
+              </a:rPr>
+              <a:t> </a:t>
+            </a:r>
+            <a:r>
+              <a:rPr lang="de-DE" dirty="0"/>
+              <a:t>and </a:t>
+            </a:r>
+            <a:r>
+              <a:rPr lang="de-DE" dirty="0">
+                <a:solidFill>
+                  <a:srgbClr val="FF0000"/>
+                </a:solidFill>
+                <a:highlight>
+                  <a:srgbClr val="84CFEF"/>
+                </a:highlight>
+              </a:rPr>
+              <a:t>[]</a:t>
+            </a:r>
+            <a:r>
+              <a:rPr lang="de-DE" dirty="0">
+                <a:solidFill>
+                  <a:srgbClr val="FF0000"/>
+                </a:solidFill>
+              </a:rPr>
+              <a:t> </a:t>
+            </a:r>
+            <a:r>
+              <a:rPr lang="de-DE" dirty="0"/>
+              <a:t>and </a:t>
+            </a:r>
+            <a:r>
+              <a:rPr lang="de-DE" sz="3600" dirty="0"/>
+              <a:t>[]</a:t>
+            </a:r>
+            <a:endParaRPr lang="de-DE" dirty="0"/>
+          </a:p>
+          <a:p>
+            <a:pPr marL="0" indent="0">
+              <a:spcBef>
+                <a:spcPts val="0"/>
+              </a:spcBef>
+              <a:buFont typeface="Arial" panose="020B0604020202020204" pitchFamily="34" charset="0"/>
+              <a:buNone/>
+            </a:pPr>
+            <a:r>
+              <a:rPr lang="de-DE" dirty="0"/>
+              <a:t>xxx [] xxx</a:t>
+            </a:r>
+          </a:p>
+          <a:p>
+            <a:pPr marL="0" indent="0">
+              <a:spcBef>
+                <a:spcPts val="0"/>
+              </a:spcBef>
+              <a:buFont typeface="Arial" panose="020B0604020202020204" pitchFamily="34" charset="0"/>
+              <a:buNone/>
+            </a:pPr>
+            <a:r>
+              <a:rPr lang="de-DE" dirty="0"/>
+              <a:t>xxx </a:t>
+            </a:r>
+            <a:r>
+              <a:rPr lang="de-DE" dirty="0">
+                <a:solidFill>
+                  <a:srgbClr val="00B0F0"/>
+                </a:solidFill>
+                <a:highlight>
+                  <a:srgbClr val="00FFFF"/>
+                </a:highlight>
+              </a:rPr>
+              <a:t>[]</a:t>
+            </a:r>
+            <a:r>
+              <a:rPr lang="de-DE" dirty="0"/>
+              <a:t> xxx</a:t>
+            </a:r>
+            <a:endParaRPr lang="de-DE" dirty="0">
+              <a:solidFill>
+                <a:srgbClr val="00B0F0"/>
+              </a:solidFill>
+            </a:endParaRPr>
+          </a:p>
+          <a:p>
+            <a:pPr marL="0" indent="0">
+              <a:spcBef>
+                <a:spcPts val="0"/>
+              </a:spcBef>
+              <a:buFont typeface="Arial" panose="020B0604020202020204" pitchFamily="34" charset="0"/>
+              <a:buNone/>
+            </a:pPr>
+            <a:r>
+              <a:rPr lang="de-DE" dirty="0">
+                <a:solidFill>
+                  <a:srgbClr val="00B050"/>
+                </a:solidFill>
+              </a:rPr>
+              <a:t>xxx </a:t>
+            </a:r>
+            <a:r>
+              <a:rPr lang="de-DE" sz="1400" dirty="0">
+                <a:solidFill>
+                  <a:srgbClr val="00B050"/>
+                </a:solidFill>
+              </a:rPr>
+              <a:t>[]</a:t>
+            </a:r>
+            <a:r>
+              <a:rPr lang="de-DE" dirty="0">
+                <a:solidFill>
+                  <a:srgbClr val="00B050"/>
+                </a:solidFill>
+              </a:rPr>
+              <a:t> xxx</a:t>
+            </a:r>
+          </a:p>
+          <a:p>
+            <a:pPr marL="0" indent="0">
+              <a:buFont typeface="Arial" panose="020B0604020202020204" pitchFamily="34" charset="0"/>
+              <a:buNone/>
+            </a:pPr>
+            <a:endParaRPr lang="de-DE" dirty="0">
+              <a:solidFill>
+                <a:srgbClr val="00B050"/>
+              </a:solidFill>
+            </a:endParaRPr>
+          </a:p>
+          <a:p>
+            <a:pPr marL="0" indent="0">
+              <a:buFont typeface="Arial" panose="020B0604020202020204" pitchFamily="34" charset="0"/>
+              <a:buNone/>
+            </a:pPr>
+            <a:endParaRPr lang="de-DE" dirty="0"/>
+          </a:p>
+        </p:txBody>
+      </p:sp>
+      <p:sp>
+        <p:nvSpPr>
+          <p:cNvPr id="6" name="Rechteck 5">
+            <a:extLst>
+              <a:ext uri="{FF2B5EF4-FFF2-40B4-BE49-F238E27FC236}">
+                <a16:creationId xmlns:a16="http://schemas.microsoft.com/office/drawing/2014/main" id="{B255A772-EECD-7916-5F37-07ADA0216337}"/>
+              </a:ext>
+            </a:extLst>
+          </p:cNvPr>
+          <p:cNvSpPr/>
+          <p:nvPr/>
+        </p:nvSpPr>
+        <p:spPr>
+          <a:xfrm>
+            <a:off x="5731520" y="1436925"/>
+            <a:ext cx="2955279" cy="2304256"/>
+          </a:xfrm>
+          <a:prstGeom prst="rect">
+            <a:avLst/>
+          </a:prstGeom>
+          <a:solidFill>
+            <a:schemeClr val="accent3"/>
+          </a:solidFill>
+          <a:ln>
+            <a:noFill/>
+          </a:ln>
+        </p:spPr>
+        <p:style>
+          <a:lnRef idx="2">
+            <a:schemeClr val="accent1">
+              <a:shade val="50000"/>
+            </a:schemeClr>
+          </a:lnRef>
+          <a:fillRef idx="1">
+            <a:schemeClr val="accent1"/>
+          </a:fillRef>
+          <a:effectRef idx="0">
+            <a:schemeClr val="accent1"/>
+          </a:effectRef>
+          <a:fontRef idx="minor">
+            <a:schemeClr val="lt1"/>
+          </a:fontRef>
+        </p:style>
+        <p:txBody>
+          <a:bodyPr lIns="72000" tIns="72000" rIns="72000" bIns="72000" rtlCol="0" anchor="ctr"/>
+          <a:lstStyle/>
+          <a:p>
+            <a:pPr algn="ctr">
+              <a:buClr>
+                <a:schemeClr val="accent2"/>
+              </a:buClr>
+            </a:pPr>
+            <a:r>
+              <a:rPr lang="de-DE" sz="1600" dirty="0">
+                <a:solidFill>
+                  <a:schemeClr val="tx1"/>
+                </a:solidFill>
+              </a:rPr>
+              <a:t>Inside </a:t>
+            </a:r>
+            <a:r>
+              <a:rPr lang="de-DE" sz="1600" dirty="0" err="1">
+                <a:solidFill>
+                  <a:schemeClr val="tx1"/>
+                </a:solidFill>
+              </a:rPr>
+              <a:t>shape</a:t>
+            </a:r>
+            <a:r>
+              <a:rPr lang="de-DE" sz="1600" dirty="0">
+                <a:solidFill>
+                  <a:schemeClr val="tx1"/>
+                </a:solidFill>
+              </a:rPr>
+              <a:t> </a:t>
+            </a:r>
+            <a:r>
+              <a:rPr lang="de-DE" sz="1600" b="1" dirty="0">
+                <a:solidFill>
+                  <a:schemeClr val="tx1"/>
+                </a:solidFill>
+                <a:highlight>
+                  <a:srgbClr val="FF0000"/>
+                </a:highlight>
+              </a:rPr>
+              <a:t>[</a:t>
+            </a:r>
+            <a:r>
+              <a:rPr lang="de-DE" sz="1600" dirty="0">
+                <a:solidFill>
+                  <a:schemeClr val="tx1"/>
+                </a:solidFill>
+                <a:highlight>
+                  <a:srgbClr val="FF0000"/>
+                </a:highlight>
+              </a:rPr>
+              <a:t>2]</a:t>
+            </a:r>
+          </a:p>
+        </p:txBody>
+      </p:sp>
+      <p:sp>
+        <p:nvSpPr>
+          <p:cNvPr id="7" name="Rechteck 6">
+            <a:extLst>
+              <a:ext uri="{FF2B5EF4-FFF2-40B4-BE49-F238E27FC236}">
+                <a16:creationId xmlns:a16="http://schemas.microsoft.com/office/drawing/2014/main" id="{C50C0EB4-DC2C-ECEE-E6AF-B136605D7A5A}"/>
+              </a:ext>
+            </a:extLst>
+          </p:cNvPr>
+          <p:cNvSpPr/>
+          <p:nvPr/>
+        </p:nvSpPr>
+        <p:spPr>
+          <a:xfrm>
+            <a:off x="5728568" y="4005064"/>
+            <a:ext cx="2955279" cy="2304256"/>
+          </a:xfrm>
+          <a:prstGeom prst="rect">
+            <a:avLst/>
+          </a:prstGeom>
+          <a:solidFill>
+            <a:schemeClr val="accent3">
+              <a:lumMod val="40000"/>
+              <a:lumOff val="60000"/>
+            </a:schemeClr>
+          </a:solidFill>
+          <a:ln>
+            <a:noFill/>
+          </a:ln>
+        </p:spPr>
+        <p:style>
+          <a:lnRef idx="2">
+            <a:schemeClr val="accent1">
+              <a:shade val="50000"/>
+            </a:schemeClr>
+          </a:lnRef>
+          <a:fillRef idx="1">
+            <a:schemeClr val="accent1"/>
+          </a:fillRef>
+          <a:effectRef idx="0">
+            <a:schemeClr val="accent1"/>
+          </a:effectRef>
+          <a:fontRef idx="minor">
+            <a:schemeClr val="lt1"/>
+          </a:fontRef>
+        </p:style>
+        <p:txBody>
+          <a:bodyPr lIns="72000" tIns="72000" rIns="72000" bIns="72000" rtlCol="0" anchor="ctr"/>
+          <a:lstStyle/>
+          <a:p>
+            <a:pPr algn="ctr">
+              <a:buClr>
+                <a:schemeClr val="accent2"/>
+              </a:buClr>
+            </a:pPr>
+            <a:r>
+              <a:rPr lang="de-DE" sz="1600" dirty="0">
+                <a:solidFill>
+                  <a:schemeClr val="tx1"/>
+                </a:solidFill>
+              </a:rPr>
+              <a:t>Inside </a:t>
+            </a:r>
+            <a:r>
+              <a:rPr lang="de-DE" sz="1600" dirty="0" err="1">
+                <a:solidFill>
+                  <a:schemeClr val="tx1"/>
+                </a:solidFill>
+              </a:rPr>
+              <a:t>shape</a:t>
+            </a:r>
+            <a:r>
+              <a:rPr lang="de-DE" sz="1600" dirty="0">
+                <a:solidFill>
+                  <a:schemeClr val="tx1"/>
+                </a:solidFill>
+              </a:rPr>
+              <a:t> </a:t>
+            </a:r>
+            <a:r>
+              <a:rPr lang="de-DE" sz="1600" b="1" dirty="0">
+                <a:solidFill>
+                  <a:srgbClr val="00B0F0"/>
+                </a:solidFill>
+              </a:rPr>
+              <a:t>[]</a:t>
+            </a:r>
+          </a:p>
+        </p:txBody>
+      </p:sp>
+    </p:spTree>
+    <p:extLst>
+      <p:ext uri="{BB962C8B-B14F-4D97-AF65-F5344CB8AC3E}">
+        <p14:creationId xmlns:p14="http://schemas.microsoft.com/office/powerpoint/2010/main" val="2101682614"/>
       </p:ext>
     </p:extLst>
   </p:cSld>

</xml_diff>